<commit_message>
add lesson8 and fix
</commit_message>
<xml_diff>
--- a/lesson_7/applicability-domain_2026_07_07.pptx
+++ b/lesson_7/applicability-domain_2026_07_07.pptx
@@ -2792,7 +2792,7 @@
           <a:p>
             <a:fld id="{5BCAD085-E8A6-8845-BD4E-CB4CCA059FC4}" type="datetimeFigureOut">
               <a:rPr lang="en-US" smtClean="0"/>
-              <a:t>7/6/26</a:t>
+              <a:t>7/7/26</a:t>
             </a:fld>
             <a:endParaRPr lang="en-US"/>
           </a:p>
@@ -2960,7 +2960,7 @@
           <a:p>
             <a:fld id="{5BCAD085-E8A6-8845-BD4E-CB4CCA059FC4}" type="datetimeFigureOut">
               <a:rPr lang="en-US" smtClean="0"/>
-              <a:t>7/6/26</a:t>
+              <a:t>7/7/26</a:t>
             </a:fld>
             <a:endParaRPr lang="en-US"/>
           </a:p>
@@ -3138,7 +3138,7 @@
           <a:p>
             <a:fld id="{5BCAD085-E8A6-8845-BD4E-CB4CCA059FC4}" type="datetimeFigureOut">
               <a:rPr lang="en-US" smtClean="0"/>
-              <a:t>7/6/26</a:t>
+              <a:t>7/7/26</a:t>
             </a:fld>
             <a:endParaRPr lang="en-US"/>
           </a:p>
@@ -3306,7 +3306,7 @@
           <a:p>
             <a:fld id="{5BCAD085-E8A6-8845-BD4E-CB4CCA059FC4}" type="datetimeFigureOut">
               <a:rPr lang="en-US" smtClean="0"/>
-              <a:t>7/6/26</a:t>
+              <a:t>7/7/26</a:t>
             </a:fld>
             <a:endParaRPr lang="en-US"/>
           </a:p>
@@ -3551,7 +3551,7 @@
           <a:p>
             <a:fld id="{5BCAD085-E8A6-8845-BD4E-CB4CCA059FC4}" type="datetimeFigureOut">
               <a:rPr lang="en-US" smtClean="0"/>
-              <a:t>7/6/26</a:t>
+              <a:t>7/7/26</a:t>
             </a:fld>
             <a:endParaRPr lang="en-US"/>
           </a:p>
@@ -3836,7 +3836,7 @@
           <a:p>
             <a:fld id="{5BCAD085-E8A6-8845-BD4E-CB4CCA059FC4}" type="datetimeFigureOut">
               <a:rPr lang="en-US" smtClean="0"/>
-              <a:t>7/6/26</a:t>
+              <a:t>7/7/26</a:t>
             </a:fld>
             <a:endParaRPr lang="en-US"/>
           </a:p>
@@ -4255,7 +4255,7 @@
           <a:p>
             <a:fld id="{5BCAD085-E8A6-8845-BD4E-CB4CCA059FC4}" type="datetimeFigureOut">
               <a:rPr lang="en-US" smtClean="0"/>
-              <a:t>7/6/26</a:t>
+              <a:t>7/7/26</a:t>
             </a:fld>
             <a:endParaRPr lang="en-US"/>
           </a:p>
@@ -4372,7 +4372,7 @@
           <a:p>
             <a:fld id="{5BCAD085-E8A6-8845-BD4E-CB4CCA059FC4}" type="datetimeFigureOut">
               <a:rPr lang="en-US" smtClean="0"/>
-              <a:t>7/6/26</a:t>
+              <a:t>7/7/26</a:t>
             </a:fld>
             <a:endParaRPr lang="en-US"/>
           </a:p>
@@ -4467,7 +4467,7 @@
           <a:p>
             <a:fld id="{5BCAD085-E8A6-8845-BD4E-CB4CCA059FC4}" type="datetimeFigureOut">
               <a:rPr lang="en-US" smtClean="0"/>
-              <a:t>7/6/26</a:t>
+              <a:t>7/7/26</a:t>
             </a:fld>
             <a:endParaRPr lang="en-US"/>
           </a:p>
@@ -4742,7 +4742,7 @@
           <a:p>
             <a:fld id="{5BCAD085-E8A6-8845-BD4E-CB4CCA059FC4}" type="datetimeFigureOut">
               <a:rPr lang="en-US" smtClean="0"/>
-              <a:t>7/6/26</a:t>
+              <a:t>7/7/26</a:t>
             </a:fld>
             <a:endParaRPr lang="en-US"/>
           </a:p>
@@ -4994,7 +4994,7 @@
           <a:p>
             <a:fld id="{5BCAD085-E8A6-8845-BD4E-CB4CCA059FC4}" type="datetimeFigureOut">
               <a:rPr lang="en-US" smtClean="0"/>
-              <a:t>7/6/26</a:t>
+              <a:t>7/7/26</a:t>
             </a:fld>
             <a:endParaRPr lang="en-US"/>
           </a:p>
@@ -5205,7 +5205,7 @@
           <a:p>
             <a:fld id="{5BCAD085-E8A6-8845-BD4E-CB4CCA059FC4}" type="datetimeFigureOut">
               <a:rPr lang="en-US" smtClean="0"/>
-              <a:t>7/6/26</a:t>
+              <a:t>7/7/26</a:t>
             </a:fld>
             <a:endParaRPr lang="en-US"/>
           </a:p>

</xml_diff>